<commit_message>
Updated technical doc, PPT and removed APK from git track
</commit_message>
<xml_diff>
--- a/MKN_Sai_Varun_NHAI_Submission_7.0.pptx
+++ b/MKN_Sai_Varun_NHAI_Submission_7.0.pptx
@@ -13149,7 +13149,7 @@
               <a:buNone/>
             </a:pPr>
             <a:r>
-              <a:rPr lang="en-US" sz="3000" b="1" dirty="0">
+              <a:rPr lang="en-US" sz="3000" b="1">
                 <a:solidFill>
                   <a:srgbClr val="00C6FF"/>
                 </a:solidFill>
@@ -13157,7 +13157,18 @@
                 <a:ea typeface="Arial Black" pitchFamily="34" charset="-122"/>
                 <a:cs typeface="Arial Black" pitchFamily="34" charset="-120"/>
               </a:rPr>
-              <a:t>170 MB</a:t>
+              <a:t>132 </a:t>
+            </a:r>
+            <a:r>
+              <a:rPr lang="en-US" sz="3000" b="1" dirty="0">
+                <a:solidFill>
+                  <a:srgbClr val="00C6FF"/>
+                </a:solidFill>
+                <a:latin typeface="Arial Black" pitchFamily="34" charset="0"/>
+                <a:ea typeface="Arial Black" pitchFamily="34" charset="-122"/>
+                <a:cs typeface="Arial Black" pitchFamily="34" charset="-120"/>
+              </a:rPr>
+              <a:t>MB</a:t>
             </a:r>
             <a:endParaRPr lang="en-US" sz="3000" dirty="0"/>
           </a:p>

</xml_diff>